<commit_message>
actualización de la presentación de prueba
</commit_message>
<xml_diff>
--- a/Registro/Pres/plantilla.pptx
+++ b/Registro/Pres/plantilla.pptx
@@ -294,7 +294,7 @@
             <a:fld id="{CFACC4EE-0BEF-1646-BAF7-943324C0CB09}" type="datetimeFigureOut">
               <a:rPr lang="es-MX" smtClean="0"/>
               <a:pPr/>
-              <a:t>01/12/21</a:t>
+              <a:t>03/12/21</a:t>
             </a:fld>
             <a:endParaRPr lang="es-MX"/>
           </a:p>
@@ -852,7 +852,7 @@
           <a:p>
             <a:fld id="{CFACC4EE-0BEF-1646-BAF7-943324C0CB09}" type="datetimeFigureOut">
               <a:rPr lang="es-MX" smtClean="0"/>
-              <a:t>01/12/21</a:t>
+              <a:t>03/12/21</a:t>
             </a:fld>
             <a:endParaRPr lang="es-MX"/>
           </a:p>
@@ -1062,7 +1062,7 @@
           <a:p>
             <a:fld id="{CFACC4EE-0BEF-1646-BAF7-943324C0CB09}" type="datetimeFigureOut">
               <a:rPr lang="es-MX" smtClean="0"/>
-              <a:t>01/12/21</a:t>
+              <a:t>03/12/21</a:t>
             </a:fld>
             <a:endParaRPr lang="es-MX"/>
           </a:p>
@@ -1313,7 +1313,7 @@
             <a:fld id="{CFACC4EE-0BEF-1646-BAF7-943324C0CB09}" type="datetimeFigureOut">
               <a:rPr lang="es-MX" smtClean="0"/>
               <a:pPr/>
-              <a:t>01/12/21</a:t>
+              <a:t>03/12/21</a:t>
             </a:fld>
             <a:endParaRPr lang="es-MX"/>
           </a:p>
@@ -1742,7 +1742,7 @@
             <a:fld id="{CFACC4EE-0BEF-1646-BAF7-943324C0CB09}" type="datetimeFigureOut">
               <a:rPr lang="es-MX" smtClean="0"/>
               <a:pPr/>
-              <a:t>01/12/21</a:t>
+              <a:t>03/12/21</a:t>
             </a:fld>
             <a:endParaRPr lang="es-MX"/>
           </a:p>
@@ -2153,6 +2153,102 @@
         <p:spPr>
           <a:xfrm>
             <a:off x="838200" y="1825625"/>
+            <a:ext cx="4851400" cy="4067427"/>
+          </a:xfrm>
+        </p:spPr>
+        <p:txBody>
+          <a:bodyPr>
+            <a:normAutofit/>
+          </a:bodyPr>
+          <a:lstStyle>
+            <a:lvl1pPr algn="just">
+              <a:defRPr sz="2000">
+                <a:latin typeface="Poppins" pitchFamily="2" charset="77"/>
+                <a:cs typeface="Poppins" pitchFamily="2" charset="77"/>
+              </a:defRPr>
+            </a:lvl1pPr>
+            <a:lvl2pPr algn="just">
+              <a:defRPr sz="2000">
+                <a:latin typeface="Poppins" pitchFamily="2" charset="77"/>
+                <a:cs typeface="Poppins" pitchFamily="2" charset="77"/>
+              </a:defRPr>
+            </a:lvl2pPr>
+            <a:lvl3pPr algn="just">
+              <a:defRPr sz="2000">
+                <a:latin typeface="Poppins" pitchFamily="2" charset="77"/>
+                <a:cs typeface="Poppins" pitchFamily="2" charset="77"/>
+              </a:defRPr>
+            </a:lvl3pPr>
+            <a:lvl4pPr algn="just">
+              <a:defRPr sz="2000">
+                <a:latin typeface="Poppins" pitchFamily="2" charset="77"/>
+                <a:cs typeface="Poppins" pitchFamily="2" charset="77"/>
+              </a:defRPr>
+            </a:lvl4pPr>
+            <a:lvl5pPr algn="just">
+              <a:defRPr sz="2000">
+                <a:latin typeface="Poppins" pitchFamily="2" charset="77"/>
+                <a:cs typeface="Poppins" pitchFamily="2" charset="77"/>
+              </a:defRPr>
+            </a:lvl5pPr>
+          </a:lstStyle>
+          <a:p>
+            <a:pPr lvl="0"/>
+            <a:r>
+              <a:rPr lang="es-MX"/>
+              <a:t>Haga clic para modificar los estilos de texto del patrón</a:t>
+            </a:r>
+          </a:p>
+          <a:p>
+            <a:pPr lvl="1"/>
+            <a:r>
+              <a:rPr lang="es-MX"/>
+              <a:t>Segundo nivel</a:t>
+            </a:r>
+          </a:p>
+          <a:p>
+            <a:pPr lvl="2"/>
+            <a:r>
+              <a:rPr lang="es-MX"/>
+              <a:t>Tercer nivel</a:t>
+            </a:r>
+          </a:p>
+          <a:p>
+            <a:pPr lvl="3"/>
+            <a:r>
+              <a:rPr lang="es-MX"/>
+              <a:t>Cuarto nivel</a:t>
+            </a:r>
+          </a:p>
+          <a:p>
+            <a:pPr lvl="4"/>
+            <a:r>
+              <a:rPr lang="es-MX"/>
+              <a:t>Quinto nivel</a:t>
+            </a:r>
+            <a:endParaRPr/>
+          </a:p>
+        </p:txBody>
+      </p:sp>
+      <p:sp>
+        <p:nvSpPr>
+          <p:cNvPr id="4" name="Marcador de contenido 3">
+            <a:extLst>
+              <a:ext uri="{FF2B5EF4-FFF2-40B4-BE49-F238E27FC236}">
+                <a16:creationId xmlns:a16="http://schemas.microsoft.com/office/drawing/2014/main" id="{31AAFE82-0E75-CA44-9DCA-9F2D683440E6}"/>
+              </a:ext>
+            </a:extLst>
+          </p:cNvPr>
+          <p:cNvSpPr>
+            <a:spLocks noGrp="1"/>
+          </p:cNvSpPr>
+          <p:nvPr>
+            <p:ph sz="half" idx="2"/>
+          </p:nvPr>
+        </p:nvSpPr>
+        <p:spPr>
+          <a:xfrm>
+            <a:off x="6172200" y="1825625"/>
             <a:ext cx="5181600" cy="4067427"/>
           </a:xfrm>
         </p:spPr>
@@ -2230,26 +2326,21 @@
       </p:sp>
       <p:sp>
         <p:nvSpPr>
-          <p:cNvPr id="4" name="Marcador de contenido 3">
-            <a:extLst>
-              <a:ext uri="{FF2B5EF4-FFF2-40B4-BE49-F238E27FC236}">
-                <a16:creationId xmlns:a16="http://schemas.microsoft.com/office/drawing/2014/main" id="{31AAFE82-0E75-CA44-9DCA-9F2D683440E6}"/>
-              </a:ext>
-            </a:extLst>
-          </p:cNvPr>
-          <p:cNvSpPr>
-            <a:spLocks noGrp="1"/>
-          </p:cNvSpPr>
-          <p:nvPr>
-            <p:ph sz="half" idx="2"/>
-          </p:nvPr>
-        </p:nvSpPr>
-        <p:spPr>
-          <a:xfrm>
-            <a:off x="6172200" y="1825625"/>
-            <a:ext cx="5181600" cy="4067427"/>
-          </a:xfrm>
-        </p:spPr>
+          <p:cNvPr id="5" name="Marcador de fecha 4">
+            <a:extLst>
+              <a:ext uri="{FF2B5EF4-FFF2-40B4-BE49-F238E27FC236}">
+                <a16:creationId xmlns:a16="http://schemas.microsoft.com/office/drawing/2014/main" id="{6045E9CD-10B1-D442-A541-E733CFC085ED}"/>
+              </a:ext>
+            </a:extLst>
+          </p:cNvPr>
+          <p:cNvSpPr>
+            <a:spLocks noGrp="1"/>
+          </p:cNvSpPr>
+          <p:nvPr>
+            <p:ph type="dt" sz="half" idx="10"/>
+          </p:nvPr>
+        </p:nvSpPr>
+        <p:spPr/>
         <p:txBody>
           <a:bodyPr/>
           <a:lstStyle>
@@ -2259,101 +2350,12 @@
                 <a:cs typeface="Poppins" pitchFamily="2" charset="77"/>
               </a:defRPr>
             </a:lvl1pPr>
-            <a:lvl2pPr>
-              <a:defRPr>
-                <a:latin typeface="Poppins" pitchFamily="2" charset="77"/>
-                <a:cs typeface="Poppins" pitchFamily="2" charset="77"/>
-              </a:defRPr>
-            </a:lvl2pPr>
-            <a:lvl3pPr>
-              <a:defRPr>
-                <a:latin typeface="Poppins" pitchFamily="2" charset="77"/>
-                <a:cs typeface="Poppins" pitchFamily="2" charset="77"/>
-              </a:defRPr>
-            </a:lvl3pPr>
-            <a:lvl4pPr>
-              <a:defRPr>
-                <a:latin typeface="Poppins" pitchFamily="2" charset="77"/>
-                <a:cs typeface="Poppins" pitchFamily="2" charset="77"/>
-              </a:defRPr>
-            </a:lvl4pPr>
-            <a:lvl5pPr>
-              <a:defRPr>
-                <a:latin typeface="Poppins" pitchFamily="2" charset="77"/>
-                <a:cs typeface="Poppins" pitchFamily="2" charset="77"/>
-              </a:defRPr>
-            </a:lvl5pPr>
-          </a:lstStyle>
-          <a:p>
-            <a:pPr lvl="0"/>
-            <a:r>
-              <a:rPr lang="es-MX"/>
-              <a:t>Haga clic para modificar los estilos de texto del patrón</a:t>
-            </a:r>
-          </a:p>
-          <a:p>
-            <a:pPr lvl="1"/>
-            <a:r>
-              <a:rPr lang="es-MX"/>
-              <a:t>Segundo nivel</a:t>
-            </a:r>
-          </a:p>
-          <a:p>
-            <a:pPr lvl="2"/>
-            <a:r>
-              <a:rPr lang="es-MX"/>
-              <a:t>Tercer nivel</a:t>
-            </a:r>
-          </a:p>
-          <a:p>
-            <a:pPr lvl="3"/>
-            <a:r>
-              <a:rPr lang="es-MX"/>
-              <a:t>Cuarto nivel</a:t>
-            </a:r>
-          </a:p>
-          <a:p>
-            <a:pPr lvl="4"/>
-            <a:r>
-              <a:rPr lang="es-MX"/>
-              <a:t>Quinto nivel</a:t>
-            </a:r>
-            <a:endParaRPr/>
-          </a:p>
-        </p:txBody>
-      </p:sp>
-      <p:sp>
-        <p:nvSpPr>
-          <p:cNvPr id="5" name="Marcador de fecha 4">
-            <a:extLst>
-              <a:ext uri="{FF2B5EF4-FFF2-40B4-BE49-F238E27FC236}">
-                <a16:creationId xmlns:a16="http://schemas.microsoft.com/office/drawing/2014/main" id="{6045E9CD-10B1-D442-A541-E733CFC085ED}"/>
-              </a:ext>
-            </a:extLst>
-          </p:cNvPr>
-          <p:cNvSpPr>
-            <a:spLocks noGrp="1"/>
-          </p:cNvSpPr>
-          <p:nvPr>
-            <p:ph type="dt" sz="half" idx="10"/>
-          </p:nvPr>
-        </p:nvSpPr>
-        <p:spPr/>
-        <p:txBody>
-          <a:bodyPr/>
-          <a:lstStyle>
-            <a:lvl1pPr>
-              <a:defRPr>
-                <a:latin typeface="Poppins" pitchFamily="2" charset="77"/>
-                <a:cs typeface="Poppins" pitchFamily="2" charset="77"/>
-              </a:defRPr>
-            </a:lvl1pPr>
           </a:lstStyle>
           <a:p>
             <a:fld id="{CFACC4EE-0BEF-1646-BAF7-943324C0CB09}" type="datetimeFigureOut">
               <a:rPr lang="es-MX" smtClean="0"/>
               <a:pPr/>
-              <a:t>01/12/21</a:t>
+              <a:t>03/12/21</a:t>
             </a:fld>
             <a:endParaRPr lang="es-MX"/>
           </a:p>
@@ -2986,7 +2988,7 @@
             <a:fld id="{CFACC4EE-0BEF-1646-BAF7-943324C0CB09}" type="datetimeFigureOut">
               <a:rPr lang="es-MX" smtClean="0"/>
               <a:pPr/>
-              <a:t>01/12/21</a:t>
+              <a:t>03/12/21</a:t>
             </a:fld>
             <a:endParaRPr lang="es-MX"/>
           </a:p>
@@ -3278,7 +3280,7 @@
             <a:fld id="{CFACC4EE-0BEF-1646-BAF7-943324C0CB09}" type="datetimeFigureOut">
               <a:rPr lang="es-MX" smtClean="0"/>
               <a:pPr/>
-              <a:t>01/12/21</a:t>
+              <a:t>03/12/21</a:t>
             </a:fld>
             <a:endParaRPr lang="es-MX"/>
           </a:p>
@@ -3526,7 +3528,7 @@
           <a:p>
             <a:fld id="{CFACC4EE-0BEF-1646-BAF7-943324C0CB09}" type="datetimeFigureOut">
               <a:rPr lang="es-MX" smtClean="0"/>
-              <a:t>01/12/21</a:t>
+              <a:t>03/12/21</a:t>
             </a:fld>
             <a:endParaRPr lang="es-MX"/>
           </a:p>
@@ -3959,7 +3961,7 @@
           <a:p>
             <a:fld id="{CFACC4EE-0BEF-1646-BAF7-943324C0CB09}" type="datetimeFigureOut">
               <a:rPr lang="es-MX" smtClean="0"/>
-              <a:t>01/12/21</a:t>
+              <a:t>03/12/21</a:t>
             </a:fld>
             <a:endParaRPr lang="es-MX"/>
           </a:p>
@@ -4368,7 +4370,7 @@
           <a:p>
             <a:fld id="{CFACC4EE-0BEF-1646-BAF7-943324C0CB09}" type="datetimeFigureOut">
               <a:rPr lang="es-MX" smtClean="0"/>
-              <a:t>01/12/21</a:t>
+              <a:t>03/12/21</a:t>
             </a:fld>
             <a:endParaRPr lang="es-MX"/>
           </a:p>
@@ -4734,7 +4736,7 @@
             <a:fld id="{CFACC4EE-0BEF-1646-BAF7-943324C0CB09}" type="datetimeFigureOut">
               <a:rPr lang="es-MX" smtClean="0"/>
               <a:pPr/>
-              <a:t>01/12/21</a:t>
+              <a:t>03/12/21</a:t>
             </a:fld>
             <a:endParaRPr lang="es-MX"/>
           </a:p>

</xml_diff>